<commit_message>
Use decorative Cyrillic Viaoda Libre for slide headings
</commit_message>
<xml_diff>
--- a/India_Dance.pptx
+++ b/India_Dance.pptx
@@ -502,7 +502,7 @@
           <a:lstStyle/>
           <a:p>
             <a:r>
-              <a:t>Слайд 1. Авторская иллюстрация танцовщицы бхаратанатьям, созданная с помощью ИИ; художественный образ, не документальная фотография. Заголовок: Noto Serif Display. Подпись: Times New Roman, 14 пт, интервал 1,5. Последовательность щелчков: заголовок, иллюстрация, авторы; проявление 0,6 с. Превью компоновки построено отдельно; воспроизведение в настольном PowerPoint требует проверки.</a:t>
+              <a:t>Слайд 1. Авторская иллюстрация танцовщицы бхаратанатьям, созданная с помощью ИИ; художественный образ, не документальная фотография. Заголовок: Viaoda Libre. Подпись: Times New Roman, 14 пт, интервал 1,5. Последовательность щелчков: заголовок, иллюстрация, авторы; проявление 0,6 с. Превью компоновки построено отдельно; воспроизведение в настольном PowerPoint требует проверки.</a:t>
             </a:r>
           </a:p>
         </p:txBody>
@@ -4474,7 +4474,7 @@
         <p:spPr>
           <a:xfrm>
             <a:off x="502920" y="1234440"/>
-            <a:ext cx="6629400" cy="731520"/>
+            <a:ext cx="6629400" cy="822960"/>
           </a:xfrm>
           <a:prstGeom prst="rect">
             <a:avLst/>
@@ -4494,11 +4494,11 @@
               <a:spcAft>
                 <a:spcPts val="0"/>
               </a:spcAft>
-              <a:defRPr sz="4600">
+              <a:defRPr sz="5000">
                 <a:solidFill>
                   <a:srgbClr val="C91E20"/>
                 </a:solidFill>
-                <a:latin typeface="Noto Serif Display"/>
+                <a:latin typeface="Viaoda Libre"/>
               </a:defRPr>
             </a:pPr>
             <a:r>
@@ -4536,11 +4536,11 @@
               <a:spcAft>
                 <a:spcPts val="0"/>
               </a:spcAft>
-              <a:defRPr sz="6000">
+              <a:defRPr sz="5400">
                 <a:solidFill>
                   <a:srgbClr val="C91E20"/>
                 </a:solidFill>
-                <a:latin typeface="Noto Serif Display"/>
+                <a:latin typeface="Viaoda Libre"/>
               </a:defRPr>
             </a:pPr>
             <a:r>
@@ -4582,7 +4582,7 @@
                 <a:solidFill>
                   <a:srgbClr val="29244F"/>
                 </a:solidFill>
-                <a:latin typeface="Noto Serif Display"/>
+                <a:latin typeface="Viaoda Libre"/>
               </a:defRPr>
             </a:pPr>
             <a:r>

</xml_diff>

<commit_message>
Create ornamental Indian title slide with editable animated text
</commit_message>
<xml_diff>
--- a/India_Dance.pptx
+++ b/India_Dance.pptx
@@ -502,7 +502,7 @@
           <a:lstStyle/>
           <a:p>
             <a:r>
-              <a:t>Слайд 1. Авторская иллюстрация танцовщицы бхаратанатьям, созданная с помощью ИИ; художественный образ, не документальная фотография. Заголовок: Viaoda Libre. Подпись: Times New Roman, 14 пт, интервал 1,5. Последовательность щелчков: заголовок, иллюстрация, авторы; проявление 0,6 с. Превью компоновки построено отдельно; воспроизведение в настольном PowerPoint требует проверки.</a:t>
+              <a:t>Орнаментальная иллюстрация подготовлена с помощью ИИ по предоставленному образцу. Текст редактируемый. Шрифты Lobster и Viaoda Libre прилагаются в архиве, их необходимо установить. Четыре щелчка: три части заголовка, затем авторы; каждая надпись плавно перемещается вверх на 3,5% высоты слайда с проявлением за 0,7 с. Воспроизведение в настольном PowerPoint не проверялось.</a:t>
             </a:r>
           </a:p>
         </p:txBody>
@@ -3510,7 +3510,7 @@
       <p:grpSpPr/>
       <p:pic>
         <p:nvPicPr>
-          <p:cNvPr id="2" name="Picture 1" descr="paper.png"/>
+          <p:cNvPr id="2" name="Picture 1" descr="ornament.png"/>
           <p:cNvPicPr>
             <a:picLocks noChangeAspect="1"/>
           </p:cNvPicPr>
@@ -3532,949 +3532,16 @@
           </a:prstGeom>
         </p:spPr>
       </p:pic>
-      <p:cxnSp>
-        <p:nvCxnSpPr>
-          <p:cNvPr id="3" name="Connector 2"/>
-          <p:cNvCxnSpPr/>
+      <p:sp>
+        <p:nvSpPr>
+          <p:cNvPr id="3" name="TextBox 2"/>
+          <p:cNvSpPr txBox="1"/>
           <p:nvPr/>
-        </p:nvCxnSpPr>
+        </p:nvSpPr>
         <p:spPr>
           <a:xfrm>
-            <a:off x="502920" y="512064"/>
-            <a:ext cx="6217920" cy="0"/>
-          </a:xfrm>
-          <a:prstGeom prst="line">
-            <a:avLst/>
-          </a:prstGeom>
-          <a:ln w="8890">
-            <a:solidFill>
-              <a:srgbClr val="C91E20"/>
-            </a:solidFill>
-          </a:ln>
-        </p:spPr>
-        <p:style>
-          <a:lnRef idx="2">
-            <a:schemeClr val="accent1"/>
-          </a:lnRef>
-          <a:fillRef idx="0">
-            <a:schemeClr val="accent1"/>
-          </a:fillRef>
-          <a:effectRef idx="1">
-            <a:schemeClr val="accent1"/>
-          </a:effectRef>
-          <a:fontRef idx="minor">
-            <a:schemeClr val="tx1"/>
-          </a:fontRef>
-        </p:style>
-      </p:cxnSp>
-      <p:cxnSp>
-        <p:nvCxnSpPr>
-          <p:cNvPr id="4" name="Connector 3"/>
-          <p:cNvCxnSpPr/>
-          <p:nvPr/>
-        </p:nvCxnSpPr>
-        <p:spPr>
-          <a:xfrm>
-            <a:off x="502920" y="6382512"/>
-            <a:ext cx="6217920" cy="0"/>
-          </a:xfrm>
-          <a:prstGeom prst="line">
-            <a:avLst/>
-          </a:prstGeom>
-          <a:ln w="8890">
-            <a:solidFill>
-              <a:srgbClr val="C91E20"/>
-            </a:solidFill>
-          </a:ln>
-        </p:spPr>
-        <p:style>
-          <a:lnRef idx="2">
-            <a:schemeClr val="accent1"/>
-          </a:lnRef>
-          <a:fillRef idx="0">
-            <a:schemeClr val="accent1"/>
-          </a:fillRef>
-          <a:effectRef idx="1">
-            <a:schemeClr val="accent1"/>
-          </a:effectRef>
-          <a:fontRef idx="minor">
-            <a:schemeClr val="tx1"/>
-          </a:fontRef>
-        </p:style>
-      </p:cxnSp>
-      <p:sp>
-        <p:nvSpPr>
-          <p:cNvPr id="5" name="Oval 4"/>
-          <p:cNvSpPr/>
-          <p:nvPr/>
-        </p:nvSpPr>
-        <p:spPr>
-          <a:xfrm>
-            <a:off x="6792163" y="491947"/>
-            <a:ext cx="40233" cy="40233"/>
-          </a:xfrm>
-          <a:prstGeom prst="ellipse">
-            <a:avLst/>
-          </a:prstGeom>
-          <a:solidFill>
-            <a:srgbClr val="C91E20"/>
-          </a:solidFill>
-          <a:ln>
-            <a:noFill/>
-          </a:ln>
-        </p:spPr>
-        <p:style>
-          <a:lnRef idx="1">
-            <a:schemeClr val="accent1"/>
-          </a:lnRef>
-          <a:fillRef idx="3">
-            <a:schemeClr val="accent1"/>
-          </a:fillRef>
-          <a:effectRef idx="2">
-            <a:schemeClr val="accent1"/>
-          </a:effectRef>
-          <a:fontRef idx="minor">
-            <a:schemeClr val="lt1"/>
-          </a:fontRef>
-        </p:style>
-        <p:txBody>
-          <a:bodyPr rtlCol="0" anchor="ctr"/>
-          <a:lstStyle/>
-          <a:p>
-            <a:pPr algn="ctr"/>
-          </a:p>
-        </p:txBody>
-      </p:sp>
-      <p:sp>
-        <p:nvSpPr>
-          <p:cNvPr id="6" name="Oval 5"/>
-          <p:cNvSpPr/>
-          <p:nvPr/>
-        </p:nvSpPr>
-        <p:spPr>
-          <a:xfrm>
-            <a:off x="6765381" y="556605"/>
-            <a:ext cx="40233" cy="40233"/>
-          </a:xfrm>
-          <a:prstGeom prst="ellipse">
-            <a:avLst/>
-          </a:prstGeom>
-          <a:solidFill>
-            <a:srgbClr val="C91E20"/>
-          </a:solidFill>
-          <a:ln>
-            <a:noFill/>
-          </a:ln>
-        </p:spPr>
-        <p:style>
-          <a:lnRef idx="1">
-            <a:schemeClr val="accent1"/>
-          </a:lnRef>
-          <a:fillRef idx="3">
-            <a:schemeClr val="accent1"/>
-          </a:fillRef>
-          <a:effectRef idx="2">
-            <a:schemeClr val="accent1"/>
-          </a:effectRef>
-          <a:fontRef idx="minor">
-            <a:schemeClr val="lt1"/>
-          </a:fontRef>
-        </p:style>
-        <p:txBody>
-          <a:bodyPr rtlCol="0" anchor="ctr"/>
-          <a:lstStyle/>
-          <a:p>
-            <a:pPr algn="ctr"/>
-          </a:p>
-        </p:txBody>
-      </p:sp>
-      <p:sp>
-        <p:nvSpPr>
-          <p:cNvPr id="7" name="Oval 6"/>
-          <p:cNvSpPr/>
-          <p:nvPr/>
-        </p:nvSpPr>
-        <p:spPr>
-          <a:xfrm>
-            <a:off x="6700723" y="583387"/>
-            <a:ext cx="40233" cy="40233"/>
-          </a:xfrm>
-          <a:prstGeom prst="ellipse">
-            <a:avLst/>
-          </a:prstGeom>
-          <a:solidFill>
-            <a:srgbClr val="C91E20"/>
-          </a:solidFill>
-          <a:ln>
-            <a:noFill/>
-          </a:ln>
-        </p:spPr>
-        <p:style>
-          <a:lnRef idx="1">
-            <a:schemeClr val="accent1"/>
-          </a:lnRef>
-          <a:fillRef idx="3">
-            <a:schemeClr val="accent1"/>
-          </a:fillRef>
-          <a:effectRef idx="2">
-            <a:schemeClr val="accent1"/>
-          </a:effectRef>
-          <a:fontRef idx="minor">
-            <a:schemeClr val="lt1"/>
-          </a:fontRef>
-        </p:style>
-        <p:txBody>
-          <a:bodyPr rtlCol="0" anchor="ctr"/>
-          <a:lstStyle/>
-          <a:p>
-            <a:pPr algn="ctr"/>
-          </a:p>
-        </p:txBody>
-      </p:sp>
-      <p:sp>
-        <p:nvSpPr>
-          <p:cNvPr id="8" name="Oval 7"/>
-          <p:cNvSpPr/>
-          <p:nvPr/>
-        </p:nvSpPr>
-        <p:spPr>
-          <a:xfrm>
-            <a:off x="6636065" y="556605"/>
-            <a:ext cx="40233" cy="40233"/>
-          </a:xfrm>
-          <a:prstGeom prst="ellipse">
-            <a:avLst/>
-          </a:prstGeom>
-          <a:solidFill>
-            <a:srgbClr val="C91E20"/>
-          </a:solidFill>
-          <a:ln>
-            <a:noFill/>
-          </a:ln>
-        </p:spPr>
-        <p:style>
-          <a:lnRef idx="1">
-            <a:schemeClr val="accent1"/>
-          </a:lnRef>
-          <a:fillRef idx="3">
-            <a:schemeClr val="accent1"/>
-          </a:fillRef>
-          <a:effectRef idx="2">
-            <a:schemeClr val="accent1"/>
-          </a:effectRef>
-          <a:fontRef idx="minor">
-            <a:schemeClr val="lt1"/>
-          </a:fontRef>
-        </p:style>
-        <p:txBody>
-          <a:bodyPr rtlCol="0" anchor="ctr"/>
-          <a:lstStyle/>
-          <a:p>
-            <a:pPr algn="ctr"/>
-          </a:p>
-        </p:txBody>
-      </p:sp>
-      <p:sp>
-        <p:nvSpPr>
-          <p:cNvPr id="9" name="Oval 8"/>
-          <p:cNvSpPr/>
-          <p:nvPr/>
-        </p:nvSpPr>
-        <p:spPr>
-          <a:xfrm>
-            <a:off x="6609283" y="491947"/>
-            <a:ext cx="40233" cy="40233"/>
-          </a:xfrm>
-          <a:prstGeom prst="ellipse">
-            <a:avLst/>
-          </a:prstGeom>
-          <a:solidFill>
-            <a:srgbClr val="C91E20"/>
-          </a:solidFill>
-          <a:ln>
-            <a:noFill/>
-          </a:ln>
-        </p:spPr>
-        <p:style>
-          <a:lnRef idx="1">
-            <a:schemeClr val="accent1"/>
-          </a:lnRef>
-          <a:fillRef idx="3">
-            <a:schemeClr val="accent1"/>
-          </a:fillRef>
-          <a:effectRef idx="2">
-            <a:schemeClr val="accent1"/>
-          </a:effectRef>
-          <a:fontRef idx="minor">
-            <a:schemeClr val="lt1"/>
-          </a:fontRef>
-        </p:style>
-        <p:txBody>
-          <a:bodyPr rtlCol="0" anchor="ctr"/>
-          <a:lstStyle/>
-          <a:p>
-            <a:pPr algn="ctr"/>
-          </a:p>
-        </p:txBody>
-      </p:sp>
-      <p:sp>
-        <p:nvSpPr>
-          <p:cNvPr id="10" name="Oval 9"/>
-          <p:cNvSpPr/>
-          <p:nvPr/>
-        </p:nvSpPr>
-        <p:spPr>
-          <a:xfrm>
-            <a:off x="6636065" y="427289"/>
-            <a:ext cx="40233" cy="40233"/>
-          </a:xfrm>
-          <a:prstGeom prst="ellipse">
-            <a:avLst/>
-          </a:prstGeom>
-          <a:solidFill>
-            <a:srgbClr val="C91E20"/>
-          </a:solidFill>
-          <a:ln>
-            <a:noFill/>
-          </a:ln>
-        </p:spPr>
-        <p:style>
-          <a:lnRef idx="1">
-            <a:schemeClr val="accent1"/>
-          </a:lnRef>
-          <a:fillRef idx="3">
-            <a:schemeClr val="accent1"/>
-          </a:fillRef>
-          <a:effectRef idx="2">
-            <a:schemeClr val="accent1"/>
-          </a:effectRef>
-          <a:fontRef idx="minor">
-            <a:schemeClr val="lt1"/>
-          </a:fontRef>
-        </p:style>
-        <p:txBody>
-          <a:bodyPr rtlCol="0" anchor="ctr"/>
-          <a:lstStyle/>
-          <a:p>
-            <a:pPr algn="ctr"/>
-          </a:p>
-        </p:txBody>
-      </p:sp>
-      <p:sp>
-        <p:nvSpPr>
-          <p:cNvPr id="11" name="Oval 10"/>
-          <p:cNvSpPr/>
-          <p:nvPr/>
-        </p:nvSpPr>
-        <p:spPr>
-          <a:xfrm>
-            <a:off x="6700723" y="400507"/>
-            <a:ext cx="40233" cy="40233"/>
-          </a:xfrm>
-          <a:prstGeom prst="ellipse">
-            <a:avLst/>
-          </a:prstGeom>
-          <a:solidFill>
-            <a:srgbClr val="C91E20"/>
-          </a:solidFill>
-          <a:ln>
-            <a:noFill/>
-          </a:ln>
-        </p:spPr>
-        <p:style>
-          <a:lnRef idx="1">
-            <a:schemeClr val="accent1"/>
-          </a:lnRef>
-          <a:fillRef idx="3">
-            <a:schemeClr val="accent1"/>
-          </a:fillRef>
-          <a:effectRef idx="2">
-            <a:schemeClr val="accent1"/>
-          </a:effectRef>
-          <a:fontRef idx="minor">
-            <a:schemeClr val="lt1"/>
-          </a:fontRef>
-        </p:style>
-        <p:txBody>
-          <a:bodyPr rtlCol="0" anchor="ctr"/>
-          <a:lstStyle/>
-          <a:p>
-            <a:pPr algn="ctr"/>
-          </a:p>
-        </p:txBody>
-      </p:sp>
-      <p:sp>
-        <p:nvSpPr>
-          <p:cNvPr id="12" name="Oval 11"/>
-          <p:cNvSpPr/>
-          <p:nvPr/>
-        </p:nvSpPr>
-        <p:spPr>
-          <a:xfrm>
-            <a:off x="6765381" y="427289"/>
-            <a:ext cx="40233" cy="40233"/>
-          </a:xfrm>
-          <a:prstGeom prst="ellipse">
-            <a:avLst/>
-          </a:prstGeom>
-          <a:solidFill>
-            <a:srgbClr val="C91E20"/>
-          </a:solidFill>
-          <a:ln>
-            <a:noFill/>
-          </a:ln>
-        </p:spPr>
-        <p:style>
-          <a:lnRef idx="1">
-            <a:schemeClr val="accent1"/>
-          </a:lnRef>
-          <a:fillRef idx="3">
-            <a:schemeClr val="accent1"/>
-          </a:fillRef>
-          <a:effectRef idx="2">
-            <a:schemeClr val="accent1"/>
-          </a:effectRef>
-          <a:fontRef idx="minor">
-            <a:schemeClr val="lt1"/>
-          </a:fontRef>
-        </p:style>
-        <p:txBody>
-          <a:bodyPr rtlCol="0" anchor="ctr"/>
-          <a:lstStyle/>
-          <a:p>
-            <a:pPr algn="ctr"/>
-          </a:p>
-        </p:txBody>
-      </p:sp>
-      <p:sp>
-        <p:nvSpPr>
-          <p:cNvPr id="13" name="Oval 12"/>
-          <p:cNvSpPr/>
-          <p:nvPr/>
-        </p:nvSpPr>
-        <p:spPr>
-          <a:xfrm>
-            <a:off x="583387" y="6362395"/>
-            <a:ext cx="40233" cy="40233"/>
-          </a:xfrm>
-          <a:prstGeom prst="ellipse">
-            <a:avLst/>
-          </a:prstGeom>
-          <a:solidFill>
-            <a:srgbClr val="C91E20"/>
-          </a:solidFill>
-          <a:ln>
-            <a:noFill/>
-          </a:ln>
-        </p:spPr>
-        <p:style>
-          <a:lnRef idx="1">
-            <a:schemeClr val="accent1"/>
-          </a:lnRef>
-          <a:fillRef idx="3">
-            <a:schemeClr val="accent1"/>
-          </a:fillRef>
-          <a:effectRef idx="2">
-            <a:schemeClr val="accent1"/>
-          </a:effectRef>
-          <a:fontRef idx="minor">
-            <a:schemeClr val="lt1"/>
-          </a:fontRef>
-        </p:style>
-        <p:txBody>
-          <a:bodyPr rtlCol="0" anchor="ctr"/>
-          <a:lstStyle/>
-          <a:p>
-            <a:pPr algn="ctr"/>
-          </a:p>
-        </p:txBody>
-      </p:sp>
-      <p:sp>
-        <p:nvSpPr>
-          <p:cNvPr id="14" name="Oval 13"/>
-          <p:cNvSpPr/>
-          <p:nvPr/>
-        </p:nvSpPr>
-        <p:spPr>
-          <a:xfrm>
-            <a:off x="556605" y="6427053"/>
-            <a:ext cx="40233" cy="40233"/>
-          </a:xfrm>
-          <a:prstGeom prst="ellipse">
-            <a:avLst/>
-          </a:prstGeom>
-          <a:solidFill>
-            <a:srgbClr val="C91E20"/>
-          </a:solidFill>
-          <a:ln>
-            <a:noFill/>
-          </a:ln>
-        </p:spPr>
-        <p:style>
-          <a:lnRef idx="1">
-            <a:schemeClr val="accent1"/>
-          </a:lnRef>
-          <a:fillRef idx="3">
-            <a:schemeClr val="accent1"/>
-          </a:fillRef>
-          <a:effectRef idx="2">
-            <a:schemeClr val="accent1"/>
-          </a:effectRef>
-          <a:fontRef idx="minor">
-            <a:schemeClr val="lt1"/>
-          </a:fontRef>
-        </p:style>
-        <p:txBody>
-          <a:bodyPr rtlCol="0" anchor="ctr"/>
-          <a:lstStyle/>
-          <a:p>
-            <a:pPr algn="ctr"/>
-          </a:p>
-        </p:txBody>
-      </p:sp>
-      <p:sp>
-        <p:nvSpPr>
-          <p:cNvPr id="15" name="Oval 14"/>
-          <p:cNvSpPr/>
-          <p:nvPr/>
-        </p:nvSpPr>
-        <p:spPr>
-          <a:xfrm>
-            <a:off x="491947" y="6453835"/>
-            <a:ext cx="40233" cy="40233"/>
-          </a:xfrm>
-          <a:prstGeom prst="ellipse">
-            <a:avLst/>
-          </a:prstGeom>
-          <a:solidFill>
-            <a:srgbClr val="C91E20"/>
-          </a:solidFill>
-          <a:ln>
-            <a:noFill/>
-          </a:ln>
-        </p:spPr>
-        <p:style>
-          <a:lnRef idx="1">
-            <a:schemeClr val="accent1"/>
-          </a:lnRef>
-          <a:fillRef idx="3">
-            <a:schemeClr val="accent1"/>
-          </a:fillRef>
-          <a:effectRef idx="2">
-            <a:schemeClr val="accent1"/>
-          </a:effectRef>
-          <a:fontRef idx="minor">
-            <a:schemeClr val="lt1"/>
-          </a:fontRef>
-        </p:style>
-        <p:txBody>
-          <a:bodyPr rtlCol="0" anchor="ctr"/>
-          <a:lstStyle/>
-          <a:p>
-            <a:pPr algn="ctr"/>
-          </a:p>
-        </p:txBody>
-      </p:sp>
-      <p:sp>
-        <p:nvSpPr>
-          <p:cNvPr id="16" name="Oval 15"/>
-          <p:cNvSpPr/>
-          <p:nvPr/>
-        </p:nvSpPr>
-        <p:spPr>
-          <a:xfrm>
-            <a:off x="427289" y="6427053"/>
-            <a:ext cx="40233" cy="40233"/>
-          </a:xfrm>
-          <a:prstGeom prst="ellipse">
-            <a:avLst/>
-          </a:prstGeom>
-          <a:solidFill>
-            <a:srgbClr val="C91E20"/>
-          </a:solidFill>
-          <a:ln>
-            <a:noFill/>
-          </a:ln>
-        </p:spPr>
-        <p:style>
-          <a:lnRef idx="1">
-            <a:schemeClr val="accent1"/>
-          </a:lnRef>
-          <a:fillRef idx="3">
-            <a:schemeClr val="accent1"/>
-          </a:fillRef>
-          <a:effectRef idx="2">
-            <a:schemeClr val="accent1"/>
-          </a:effectRef>
-          <a:fontRef idx="minor">
-            <a:schemeClr val="lt1"/>
-          </a:fontRef>
-        </p:style>
-        <p:txBody>
-          <a:bodyPr rtlCol="0" anchor="ctr"/>
-          <a:lstStyle/>
-          <a:p>
-            <a:pPr algn="ctr"/>
-          </a:p>
-        </p:txBody>
-      </p:sp>
-      <p:sp>
-        <p:nvSpPr>
-          <p:cNvPr id="17" name="Oval 16"/>
-          <p:cNvSpPr/>
-          <p:nvPr/>
-        </p:nvSpPr>
-        <p:spPr>
-          <a:xfrm>
-            <a:off x="400507" y="6362395"/>
-            <a:ext cx="40233" cy="40233"/>
-          </a:xfrm>
-          <a:prstGeom prst="ellipse">
-            <a:avLst/>
-          </a:prstGeom>
-          <a:solidFill>
-            <a:srgbClr val="C91E20"/>
-          </a:solidFill>
-          <a:ln>
-            <a:noFill/>
-          </a:ln>
-        </p:spPr>
-        <p:style>
-          <a:lnRef idx="1">
-            <a:schemeClr val="accent1"/>
-          </a:lnRef>
-          <a:fillRef idx="3">
-            <a:schemeClr val="accent1"/>
-          </a:fillRef>
-          <a:effectRef idx="2">
-            <a:schemeClr val="accent1"/>
-          </a:effectRef>
-          <a:fontRef idx="minor">
-            <a:schemeClr val="lt1"/>
-          </a:fontRef>
-        </p:style>
-        <p:txBody>
-          <a:bodyPr rtlCol="0" anchor="ctr"/>
-          <a:lstStyle/>
-          <a:p>
-            <a:pPr algn="ctr"/>
-          </a:p>
-        </p:txBody>
-      </p:sp>
-      <p:sp>
-        <p:nvSpPr>
-          <p:cNvPr id="18" name="Oval 17"/>
-          <p:cNvSpPr/>
-          <p:nvPr/>
-        </p:nvSpPr>
-        <p:spPr>
-          <a:xfrm>
-            <a:off x="427289" y="6297737"/>
-            <a:ext cx="40233" cy="40233"/>
-          </a:xfrm>
-          <a:prstGeom prst="ellipse">
-            <a:avLst/>
-          </a:prstGeom>
-          <a:solidFill>
-            <a:srgbClr val="C91E20"/>
-          </a:solidFill>
-          <a:ln>
-            <a:noFill/>
-          </a:ln>
-        </p:spPr>
-        <p:style>
-          <a:lnRef idx="1">
-            <a:schemeClr val="accent1"/>
-          </a:lnRef>
-          <a:fillRef idx="3">
-            <a:schemeClr val="accent1"/>
-          </a:fillRef>
-          <a:effectRef idx="2">
-            <a:schemeClr val="accent1"/>
-          </a:effectRef>
-          <a:fontRef idx="minor">
-            <a:schemeClr val="lt1"/>
-          </a:fontRef>
-        </p:style>
-        <p:txBody>
-          <a:bodyPr rtlCol="0" anchor="ctr"/>
-          <a:lstStyle/>
-          <a:p>
-            <a:pPr algn="ctr"/>
-          </a:p>
-        </p:txBody>
-      </p:sp>
-      <p:sp>
-        <p:nvSpPr>
-          <p:cNvPr id="19" name="Oval 18"/>
-          <p:cNvSpPr/>
-          <p:nvPr/>
-        </p:nvSpPr>
-        <p:spPr>
-          <a:xfrm>
-            <a:off x="491947" y="6270955"/>
-            <a:ext cx="40233" cy="40233"/>
-          </a:xfrm>
-          <a:prstGeom prst="ellipse">
-            <a:avLst/>
-          </a:prstGeom>
-          <a:solidFill>
-            <a:srgbClr val="C91E20"/>
-          </a:solidFill>
-          <a:ln>
-            <a:noFill/>
-          </a:ln>
-        </p:spPr>
-        <p:style>
-          <a:lnRef idx="1">
-            <a:schemeClr val="accent1"/>
-          </a:lnRef>
-          <a:fillRef idx="3">
-            <a:schemeClr val="accent1"/>
-          </a:fillRef>
-          <a:effectRef idx="2">
-            <a:schemeClr val="accent1"/>
-          </a:effectRef>
-          <a:fontRef idx="minor">
-            <a:schemeClr val="lt1"/>
-          </a:fontRef>
-        </p:style>
-        <p:txBody>
-          <a:bodyPr rtlCol="0" anchor="ctr"/>
-          <a:lstStyle/>
-          <a:p>
-            <a:pPr algn="ctr"/>
-          </a:p>
-        </p:txBody>
-      </p:sp>
-      <p:sp>
-        <p:nvSpPr>
-          <p:cNvPr id="20" name="Oval 19"/>
-          <p:cNvSpPr/>
-          <p:nvPr/>
-        </p:nvSpPr>
-        <p:spPr>
-          <a:xfrm>
-            <a:off x="556605" y="6297737"/>
-            <a:ext cx="40233" cy="40233"/>
-          </a:xfrm>
-          <a:prstGeom prst="ellipse">
-            <a:avLst/>
-          </a:prstGeom>
-          <a:solidFill>
-            <a:srgbClr val="C91E20"/>
-          </a:solidFill>
-          <a:ln>
-            <a:noFill/>
-          </a:ln>
-        </p:spPr>
-        <p:style>
-          <a:lnRef idx="1">
-            <a:schemeClr val="accent1"/>
-          </a:lnRef>
-          <a:fillRef idx="3">
-            <a:schemeClr val="accent1"/>
-          </a:fillRef>
-          <a:effectRef idx="2">
-            <a:schemeClr val="accent1"/>
-          </a:effectRef>
-          <a:fontRef idx="minor">
-            <a:schemeClr val="lt1"/>
-          </a:fontRef>
-        </p:style>
-        <p:txBody>
-          <a:bodyPr rtlCol="0" anchor="ctr"/>
-          <a:lstStyle/>
-          <a:p>
-            <a:pPr algn="ctr"/>
-          </a:p>
-        </p:txBody>
-      </p:sp>
-      <p:cxnSp>
-        <p:nvCxnSpPr>
-          <p:cNvPr id="21" name="Connector 20"/>
-          <p:cNvCxnSpPr/>
-          <p:nvPr/>
-        </p:nvCxnSpPr>
-        <p:spPr>
-          <a:xfrm>
-            <a:off x="539496" y="749808"/>
-            <a:ext cx="0" cy="73152"/>
-          </a:xfrm>
-          <a:prstGeom prst="line">
-            <a:avLst/>
-          </a:prstGeom>
-          <a:ln w="15240">
-            <a:solidFill>
-              <a:srgbClr val="C91E20"/>
-            </a:solidFill>
-          </a:ln>
-        </p:spPr>
-        <p:style>
-          <a:lnRef idx="2">
-            <a:schemeClr val="accent1"/>
-          </a:lnRef>
-          <a:fillRef idx="0">
-            <a:schemeClr val="accent1"/>
-          </a:fillRef>
-          <a:effectRef idx="1">
-            <a:schemeClr val="accent1"/>
-          </a:effectRef>
-          <a:fontRef idx="minor">
-            <a:schemeClr val="tx1"/>
-          </a:fontRef>
-        </p:style>
-      </p:cxnSp>
-      <p:cxnSp>
-        <p:nvCxnSpPr>
-          <p:cNvPr id="22" name="Connector 21"/>
-          <p:cNvCxnSpPr/>
-          <p:nvPr/>
-        </p:nvCxnSpPr>
-        <p:spPr>
-          <a:xfrm>
-            <a:off x="667512" y="749808"/>
-            <a:ext cx="0" cy="137160"/>
-          </a:xfrm>
-          <a:prstGeom prst="line">
-            <a:avLst/>
-          </a:prstGeom>
-          <a:ln w="15240">
-            <a:solidFill>
-              <a:srgbClr val="C91E20"/>
-            </a:solidFill>
-          </a:ln>
-        </p:spPr>
-        <p:style>
-          <a:lnRef idx="2">
-            <a:schemeClr val="accent1"/>
-          </a:lnRef>
-          <a:fillRef idx="0">
-            <a:schemeClr val="accent1"/>
-          </a:fillRef>
-          <a:effectRef idx="1">
-            <a:schemeClr val="accent1"/>
-          </a:effectRef>
-          <a:fontRef idx="minor">
-            <a:schemeClr val="tx1"/>
-          </a:fontRef>
-        </p:style>
-      </p:cxnSp>
-      <p:cxnSp>
-        <p:nvCxnSpPr>
-          <p:cNvPr id="23" name="Connector 22"/>
-          <p:cNvCxnSpPr/>
-          <p:nvPr/>
-        </p:nvCxnSpPr>
-        <p:spPr>
-          <a:xfrm>
-            <a:off x="795528" y="749808"/>
-            <a:ext cx="0" cy="73152"/>
-          </a:xfrm>
-          <a:prstGeom prst="line">
-            <a:avLst/>
-          </a:prstGeom>
-          <a:ln w="15240">
-            <a:solidFill>
-              <a:srgbClr val="C91E20"/>
-            </a:solidFill>
-          </a:ln>
-        </p:spPr>
-        <p:style>
-          <a:lnRef idx="2">
-            <a:schemeClr val="accent1"/>
-          </a:lnRef>
-          <a:fillRef idx="0">
-            <a:schemeClr val="accent1"/>
-          </a:fillRef>
-          <a:effectRef idx="1">
-            <a:schemeClr val="accent1"/>
-          </a:effectRef>
-          <a:fontRef idx="minor">
-            <a:schemeClr val="tx1"/>
-          </a:fontRef>
-        </p:style>
-      </p:cxnSp>
-      <p:cxnSp>
-        <p:nvCxnSpPr>
-          <p:cNvPr id="24" name="Connector 23"/>
-          <p:cNvCxnSpPr/>
-          <p:nvPr/>
-        </p:nvCxnSpPr>
-        <p:spPr>
-          <a:xfrm>
-            <a:off x="923544" y="749808"/>
-            <a:ext cx="0" cy="137160"/>
-          </a:xfrm>
-          <a:prstGeom prst="line">
-            <a:avLst/>
-          </a:prstGeom>
-          <a:ln w="15240">
-            <a:solidFill>
-              <a:srgbClr val="C91E20"/>
-            </a:solidFill>
-          </a:ln>
-        </p:spPr>
-        <p:style>
-          <a:lnRef idx="2">
-            <a:schemeClr val="accent1"/>
-          </a:lnRef>
-          <a:fillRef idx="0">
-            <a:schemeClr val="accent1"/>
-          </a:fillRef>
-          <a:effectRef idx="1">
-            <a:schemeClr val="accent1"/>
-          </a:effectRef>
-          <a:fontRef idx="minor">
-            <a:schemeClr val="tx1"/>
-          </a:fontRef>
-        </p:style>
-      </p:cxnSp>
-      <p:cxnSp>
-        <p:nvCxnSpPr>
-          <p:cNvPr id="25" name="Connector 24"/>
-          <p:cNvCxnSpPr/>
-          <p:nvPr/>
-        </p:nvCxnSpPr>
-        <p:spPr>
-          <a:xfrm>
-            <a:off x="1051560" y="749808"/>
-            <a:ext cx="0" cy="73152"/>
-          </a:xfrm>
-          <a:prstGeom prst="line">
-            <a:avLst/>
-          </a:prstGeom>
-          <a:ln w="15240">
-            <a:solidFill>
-              <a:srgbClr val="C91E20"/>
-            </a:solidFill>
-          </a:ln>
-        </p:spPr>
-        <p:style>
-          <a:lnRef idx="2">
-            <a:schemeClr val="accent1"/>
-          </a:lnRef>
-          <a:fillRef idx="0">
-            <a:schemeClr val="accent1"/>
-          </a:fillRef>
-          <a:effectRef idx="1">
-            <a:schemeClr val="accent1"/>
-          </a:effectRef>
-          <a:fontRef idx="minor">
-            <a:schemeClr val="tx1"/>
-          </a:fontRef>
-        </p:style>
-      </p:cxnSp>
-      <p:sp>
-        <p:nvSpPr>
-          <p:cNvPr id="26" name="TextBox 25"/>
-          <p:cNvSpPr txBox="1"/>
-          <p:nvPr/>
-        </p:nvSpPr>
-        <p:spPr>
-          <a:xfrm>
-            <a:off x="502920" y="1234440"/>
-            <a:ext cx="6629400" cy="822960"/>
+            <a:off x="2743200" y="1965960"/>
+            <a:ext cx="6702552" cy="859536"/>
           </a:xfrm>
           <a:prstGeom prst="rect">
             <a:avLst/>
@@ -4487,18 +3554,18 @@
           </a:bodyPr>
           <a:lstStyle/>
           <a:p>
-            <a:pPr>
+            <a:pPr algn="ctr">
               <a:lnSpc>
                 <a:spcPct val="100000"/>
               </a:lnSpc>
               <a:spcAft>
                 <a:spcPts val="0"/>
               </a:spcAft>
-              <a:defRPr sz="5000">
+              <a:defRPr sz="5600" b="0">
                 <a:solidFill>
-                  <a:srgbClr val="C91E20"/>
+                  <a:srgbClr val="F4E3B5"/>
                 </a:solidFill>
-                <a:latin typeface="Viaoda Libre"/>
+                <a:latin typeface="Lobster"/>
               </a:defRPr>
             </a:pPr>
             <a:r>
@@ -4509,14 +3576,14 @@
       </p:sp>
       <p:sp>
         <p:nvSpPr>
-          <p:cNvPr id="27" name="TextBox 26"/>
+          <p:cNvPr id="4" name="TextBox 3"/>
           <p:cNvSpPr txBox="1"/>
           <p:nvPr/>
         </p:nvSpPr>
         <p:spPr>
           <a:xfrm>
-            <a:off x="502920" y="2020824"/>
-            <a:ext cx="6492240" cy="950976"/>
+            <a:off x="2395728" y="2779776"/>
+            <a:ext cx="7397496" cy="1152144"/>
           </a:xfrm>
           <a:prstGeom prst="rect">
             <a:avLst/>
@@ -4529,36 +3596,36 @@
           </a:bodyPr>
           <a:lstStyle/>
           <a:p>
-            <a:pPr>
+            <a:pPr algn="ctr">
               <a:lnSpc>
                 <a:spcPct val="100000"/>
               </a:lnSpc>
               <a:spcAft>
                 <a:spcPts val="0"/>
               </a:spcAft>
-              <a:defRPr sz="5400">
+              <a:defRPr sz="8000" b="1">
                 <a:solidFill>
-                  <a:srgbClr val="C91E20"/>
+                  <a:srgbClr val="F4E3B5"/>
                 </a:solidFill>
                 <a:latin typeface="Viaoda Libre"/>
               </a:defRPr>
             </a:pPr>
             <a:r>
-              <a:t>искусство</a:t>
-            </a:r>
-          </a:p>
-        </p:txBody>
-      </p:sp>
-      <p:sp>
-        <p:nvSpPr>
-          <p:cNvPr id="28" name="TextBox 27"/>
+              <a:t>ИСКУССТВО</a:t>
+            </a:r>
+          </a:p>
+        </p:txBody>
+      </p:sp>
+      <p:sp>
+        <p:nvSpPr>
+          <p:cNvPr id="5" name="TextBox 4"/>
           <p:cNvSpPr txBox="1"/>
           <p:nvPr/>
         </p:nvSpPr>
         <p:spPr>
           <a:xfrm>
-            <a:off x="539496" y="3127248"/>
-            <a:ext cx="6400800" cy="685800"/>
+            <a:off x="2743200" y="4050791"/>
+            <a:ext cx="6702552" cy="868680"/>
           </a:xfrm>
           <a:prstGeom prst="rect">
             <a:avLst/>
@@ -4571,16 +3638,16 @@
           </a:bodyPr>
           <a:lstStyle/>
           <a:p>
-            <a:pPr>
+            <a:pPr algn="ctr">
               <a:lnSpc>
                 <a:spcPct val="100000"/>
               </a:lnSpc>
               <a:spcAft>
                 <a:spcPts val="0"/>
               </a:spcAft>
-              <a:defRPr sz="3400">
+              <a:defRPr sz="4700" b="1">
                 <a:solidFill>
-                  <a:srgbClr val="29244F"/>
+                  <a:srgbClr val="F4E3B5"/>
                 </a:solidFill>
                 <a:latin typeface="Viaoda Libre"/>
               </a:defRPr>
@@ -4591,51 +3658,16 @@
           </a:p>
         </p:txBody>
       </p:sp>
-      <p:cxnSp>
-        <p:nvCxnSpPr>
-          <p:cNvPr id="29" name="Connector 28"/>
-          <p:cNvCxnSpPr/>
+      <p:sp>
+        <p:nvSpPr>
+          <p:cNvPr id="6" name="TextBox 5"/>
+          <p:cNvSpPr txBox="1"/>
           <p:nvPr/>
-        </p:nvCxnSpPr>
+        </p:nvSpPr>
         <p:spPr>
           <a:xfrm>
-            <a:off x="548640" y="4206240"/>
-            <a:ext cx="731520" cy="0"/>
-          </a:xfrm>
-          <a:prstGeom prst="line">
-            <a:avLst/>
-          </a:prstGeom>
-          <a:ln w="22860">
-            <a:solidFill>
-              <a:srgbClr val="C91E20"/>
-            </a:solidFill>
-          </a:ln>
-        </p:spPr>
-        <p:style>
-          <a:lnRef idx="2">
-            <a:schemeClr val="accent1"/>
-          </a:lnRef>
-          <a:fillRef idx="0">
-            <a:schemeClr val="accent1"/>
-          </a:fillRef>
-          <a:effectRef idx="1">
-            <a:schemeClr val="accent1"/>
-          </a:effectRef>
-          <a:fontRef idx="minor">
-            <a:schemeClr val="tx1"/>
-          </a:fontRef>
-        </p:style>
-      </p:cxnSp>
-      <p:sp>
-        <p:nvSpPr>
-          <p:cNvPr id="30" name="TextBox 29"/>
-          <p:cNvSpPr txBox="1"/>
-          <p:nvPr/>
-        </p:nvSpPr>
-        <p:spPr>
-          <a:xfrm>
-            <a:off x="557784" y="4782312"/>
-            <a:ext cx="6217920" cy="1188720"/>
+            <a:off x="3840480" y="5641848"/>
+            <a:ext cx="4507992" cy="658368"/>
           </a:xfrm>
           <a:prstGeom prst="rect">
             <a:avLst/>
@@ -4648,123 +3680,45 @@
           </a:bodyPr>
           <a:lstStyle/>
           <a:p>
-            <a:pPr>
+            <a:pPr algn="ctr">
               <a:lnSpc>
                 <a:spcPct val="150000"/>
               </a:lnSpc>
               <a:spcAft>
                 <a:spcPts val="0"/>
               </a:spcAft>
-              <a:defRPr sz="1400">
+              <a:defRPr sz="1400" b="0">
                 <a:solidFill>
-                  <a:srgbClr val="29244F"/>
+                  <a:srgbClr val="F4E3B5"/>
                 </a:solidFill>
                 <a:latin typeface="Times New Roman"/>
               </a:defRPr>
             </a:pPr>
             <a:r>
-              <a:t>Подготовили:</a:t>
-            </a:r>
-          </a:p>
-          <a:p>
-            <a:pPr>
+              <a:t>Подготовили: Алексейкина Алиса, Блинова Карина,</a:t>
+            </a:r>
+          </a:p>
+          <a:p>
+            <a:pPr algn="ctr">
               <a:lnSpc>
                 <a:spcPct val="150000"/>
               </a:lnSpc>
               <a:spcAft>
                 <a:spcPts val="0"/>
               </a:spcAft>
-              <a:defRPr sz="1400">
+              <a:defRPr sz="1400" b="0">
                 <a:solidFill>
-                  <a:srgbClr val="29244F"/>
+                  <a:srgbClr val="F4E3B5"/>
                 </a:solidFill>
                 <a:latin typeface="Times New Roman"/>
               </a:defRPr>
             </a:pPr>
             <a:r>
-              <a:t>Алексейкина Алиса, Блинова Карина,</a:t>
-            </a:r>
-          </a:p>
-          <a:p>
-            <a:pPr>
-              <a:lnSpc>
-                <a:spcPct val="150000"/>
-              </a:lnSpc>
-              <a:spcAft>
-                <a:spcPts val="0"/>
-              </a:spcAft>
-              <a:defRPr sz="1400">
-                <a:solidFill>
-                  <a:srgbClr val="29244F"/>
-                </a:solidFill>
-                <a:latin typeface="Times New Roman"/>
-              </a:defRPr>
-            </a:pPr>
-            <a:r>
               <a:t>Данеева Анастасия, Чеботарева Ксения</a:t>
             </a:r>
           </a:p>
         </p:txBody>
       </p:sp>
-      <p:pic>
-        <p:nvPicPr>
-          <p:cNvPr id="31" name="Picture 30" descr="dancer_crop.jpg"/>
-          <p:cNvPicPr>
-            <a:picLocks noChangeAspect="1"/>
-          </p:cNvPicPr>
-          <p:nvPr/>
-        </p:nvPicPr>
-        <p:blipFill>
-          <a:blip r:embed="rId3"/>
-          <a:stretch>
-            <a:fillRect/>
-          </a:stretch>
-        </p:blipFill>
-        <p:spPr>
-          <a:xfrm>
-            <a:off x="7315200" y="384048"/>
-            <a:ext cx="4489704" cy="6089904"/>
-          </a:xfrm>
-          <a:prstGeom prst="rect">
-            <a:avLst/>
-          </a:prstGeom>
-        </p:spPr>
-      </p:pic>
-      <p:cxnSp>
-        <p:nvCxnSpPr>
-          <p:cNvPr id="32" name="Connector 31"/>
-          <p:cNvCxnSpPr/>
-          <p:nvPr/>
-        </p:nvCxnSpPr>
-        <p:spPr>
-          <a:xfrm>
-            <a:off x="7178040" y="384048"/>
-            <a:ext cx="0" cy="6089904"/>
-          </a:xfrm>
-          <a:prstGeom prst="line">
-            <a:avLst/>
-          </a:prstGeom>
-          <a:ln w="8890">
-            <a:solidFill>
-              <a:srgbClr val="29244F"/>
-            </a:solidFill>
-          </a:ln>
-        </p:spPr>
-        <p:style>
-          <a:lnRef idx="2">
-            <a:schemeClr val="accent1"/>
-          </a:lnRef>
-          <a:fillRef idx="0">
-            <a:schemeClr val="accent1"/>
-          </a:fillRef>
-          <a:effectRef idx="1">
-            <a:schemeClr val="accent1"/>
-          </a:effectRef>
-          <a:fontRef idx="minor">
-            <a:schemeClr val="tx1"/>
-          </a:fontRef>
-        </p:style>
-      </p:cxnSp>
     </p:spTree>
   </p:cSld>
   <p:clrMapOvr>
@@ -4788,7 +3742,7 @@
                       </p:stCondLst>
                       <p:childTnLst>
                         <p:par>
-                          <p:cTn id="4" presetID="10" presetClass="entr" presetSubtype="0" fill="hold" nodeType="clickEffect">
+                          <p:cTn id="4" presetID="2" presetClass="entr" presetSubtype="4" fill="hold" nodeType="clickEffect">
                             <p:stCondLst>
                               <p:cond delay="0"/>
                             </p:stCondLst>
@@ -4801,7 +3755,7 @@
                                     </p:stCondLst>
                                   </p:cTn>
                                   <p:tgtEl>
-                                    <p:spTgt spid="26"/>
+                                    <p:spTgt spid="3"/>
                                   </p:tgtEl>
                                   <p:attrNameLst>
                                     <p:attrName>style.visibility</p:attrName>
@@ -4813,30 +3767,51 @@
                               </p:set>
                               <p:animEffect transition="in" filter="fade">
                                 <p:cBhvr>
-                                  <p:cTn id="6" dur="600"/>
+                                  <p:cTn id="6" dur="700"/>
                                   <p:tgtEl>
-                                    <p:spTgt spid="26"/>
+                                    <p:spTgt spid="3"/>
                                   </p:tgtEl>
                                 </p:cBhvr>
                               </p:animEffect>
+                              <p:animMotion origin="layout" path="M 0 0.035 L 0 0 E" pathEditMode="relative" rAng="0">
+                                <p:cBhvr additive="base">
+                                  <p:cTn id="7" dur="700" fill="hold" accel="20000" decel="50000"/>
+                                  <p:tgtEl>
+                                    <p:spTgt spid="3"/>
+                                  </p:tgtEl>
+                                  <p:attrNameLst>
+                                    <p:attrName>ppt_x</p:attrName>
+                                    <p:attrName>ppt_y</p:attrName>
+                                  </p:attrNameLst>
+                                </p:cBhvr>
+                              </p:animMotion>
                             </p:childTnLst>
                           </p:cTn>
                         </p:par>
+                      </p:childTnLst>
+                    </p:cTn>
+                  </p:par>
+                  <p:par>
+                    <p:cTn id="8" fill="hold">
+                      <p:stCondLst>
+                        <p:cond delay="indefinite"/>
+                      </p:stCondLst>
+                      <p:childTnLst>
                         <p:par>
-                          <p:cTn id="7" presetID="10" presetClass="entr" presetSubtype="0" fill="hold" nodeType="clickEffect">
+                          <p:cTn id="9" presetID="2" presetClass="entr" presetSubtype="4" fill="hold" nodeType="clickEffect">
                             <p:stCondLst>
                               <p:cond delay="0"/>
                             </p:stCondLst>
                             <p:childTnLst>
                               <p:set>
                                 <p:cBhvr>
-                                  <p:cTn id="8" dur="1" fill="hold">
+                                  <p:cTn id="10" dur="1" fill="hold">
                                     <p:stCondLst>
                                       <p:cond delay="0"/>
                                     </p:stCondLst>
                                   </p:cTn>
                                   <p:tgtEl>
-                                    <p:spTgt spid="27"/>
+                                    <p:spTgt spid="4"/>
                                   </p:tgtEl>
                                   <p:attrNameLst>
                                     <p:attrName>style.visibility</p:attrName>
@@ -4848,47 +3823,24 @@
                               </p:set>
                               <p:animEffect transition="in" filter="fade">
                                 <p:cBhvr>
-                                  <p:cTn id="9" dur="600"/>
+                                  <p:cTn id="11" dur="700"/>
                                   <p:tgtEl>
-                                    <p:spTgt spid="27"/>
+                                    <p:spTgt spid="4"/>
                                   </p:tgtEl>
                                 </p:cBhvr>
                               </p:animEffect>
-                            </p:childTnLst>
-                          </p:cTn>
-                        </p:par>
-                        <p:par>
-                          <p:cTn id="10" presetID="10" presetClass="entr" presetSubtype="0" fill="hold" nodeType="clickEffect">
-                            <p:stCondLst>
-                              <p:cond delay="0"/>
-                            </p:stCondLst>
-                            <p:childTnLst>
-                              <p:set>
-                                <p:cBhvr>
-                                  <p:cTn id="11" dur="1" fill="hold">
-                                    <p:stCondLst>
-                                      <p:cond delay="0"/>
-                                    </p:stCondLst>
-                                  </p:cTn>
+                              <p:animMotion origin="layout" path="M 0 0.035 L 0 0 E" pathEditMode="relative" rAng="0">
+                                <p:cBhvr additive="base">
+                                  <p:cTn id="12" dur="700" fill="hold" accel="20000" decel="50000"/>
                                   <p:tgtEl>
-                                    <p:spTgt spid="28"/>
+                                    <p:spTgt spid="4"/>
                                   </p:tgtEl>
                                   <p:attrNameLst>
-                                    <p:attrName>style.visibility</p:attrName>
+                                    <p:attrName>ppt_x</p:attrName>
+                                    <p:attrName>ppt_y</p:attrName>
                                   </p:attrNameLst>
                                 </p:cBhvr>
-                                <p:to>
-                                  <p:strVal val="visible"/>
-                                </p:to>
-                              </p:set>
-                              <p:animEffect transition="in" filter="fade">
-                                <p:cBhvr>
-                                  <p:cTn id="12" dur="600"/>
-                                  <p:tgtEl>
-                                    <p:spTgt spid="28"/>
-                                  </p:tgtEl>
-                                </p:cBhvr>
-                              </p:animEffect>
+                              </p:animMotion>
                             </p:childTnLst>
                           </p:cTn>
                         </p:par>
@@ -4902,7 +3854,7 @@
                       </p:stCondLst>
                       <p:childTnLst>
                         <p:par>
-                          <p:cTn id="14" presetID="10" presetClass="entr" presetSubtype="0" fill="hold" nodeType="clickEffect">
+                          <p:cTn id="14" presetID="2" presetClass="entr" presetSubtype="4" fill="hold" nodeType="clickEffect">
                             <p:stCondLst>
                               <p:cond delay="0"/>
                             </p:stCondLst>
@@ -4915,7 +3867,7 @@
                                     </p:stCondLst>
                                   </p:cTn>
                                   <p:tgtEl>
-                                    <p:spTgt spid="31"/>
+                                    <p:spTgt spid="5"/>
                                   </p:tgtEl>
                                   <p:attrNameLst>
                                     <p:attrName>style.visibility</p:attrName>
@@ -4927,12 +3879,24 @@
                               </p:set>
                               <p:animEffect transition="in" filter="fade">
                                 <p:cBhvr>
-                                  <p:cTn id="16" dur="600"/>
+                                  <p:cTn id="16" dur="700"/>
                                   <p:tgtEl>
-                                    <p:spTgt spid="31"/>
+                                    <p:spTgt spid="5"/>
                                   </p:tgtEl>
                                 </p:cBhvr>
                               </p:animEffect>
+                              <p:animMotion origin="layout" path="M 0 0.035 L 0 0 E" pathEditMode="relative" rAng="0">
+                                <p:cBhvr additive="base">
+                                  <p:cTn id="17" dur="700" fill="hold" accel="20000" decel="50000"/>
+                                  <p:tgtEl>
+                                    <p:spTgt spid="5"/>
+                                  </p:tgtEl>
+                                  <p:attrNameLst>
+                                    <p:attrName>ppt_x</p:attrName>
+                                    <p:attrName>ppt_y</p:attrName>
+                                  </p:attrNameLst>
+                                </p:cBhvr>
+                              </p:animMotion>
                             </p:childTnLst>
                           </p:cTn>
                         </p:par>
@@ -4940,26 +3904,26 @@
                     </p:cTn>
                   </p:par>
                   <p:par>
-                    <p:cTn id="17" fill="hold">
+                    <p:cTn id="18" fill="hold">
                       <p:stCondLst>
                         <p:cond delay="indefinite"/>
                       </p:stCondLst>
                       <p:childTnLst>
                         <p:par>
-                          <p:cTn id="18" presetID="10" presetClass="entr" presetSubtype="0" fill="hold" nodeType="clickEffect">
+                          <p:cTn id="19" presetID="2" presetClass="entr" presetSubtype="4" fill="hold" nodeType="clickEffect">
                             <p:stCondLst>
                               <p:cond delay="0"/>
                             </p:stCondLst>
                             <p:childTnLst>
                               <p:set>
                                 <p:cBhvr>
-                                  <p:cTn id="19" dur="1" fill="hold">
+                                  <p:cTn id="20" dur="1" fill="hold">
                                     <p:stCondLst>
                                       <p:cond delay="0"/>
                                     </p:stCondLst>
                                   </p:cTn>
                                   <p:tgtEl>
-                                    <p:spTgt spid="30"/>
+                                    <p:spTgt spid="6"/>
                                   </p:tgtEl>
                                   <p:attrNameLst>
                                     <p:attrName>style.visibility</p:attrName>
@@ -4971,12 +3935,24 @@
                               </p:set>
                               <p:animEffect transition="in" filter="fade">
                                 <p:cBhvr>
-                                  <p:cTn id="20" dur="600"/>
+                                  <p:cTn id="21" dur="700"/>
                                   <p:tgtEl>
-                                    <p:spTgt spid="30"/>
+                                    <p:spTgt spid="6"/>
                                   </p:tgtEl>
                                 </p:cBhvr>
                               </p:animEffect>
+                              <p:animMotion origin="layout" path="M 0 0.035 L 0 0 E" pathEditMode="relative" rAng="0">
+                                <p:cBhvr additive="base">
+                                  <p:cTn id="22" dur="700" fill="hold" accel="20000" decel="50000"/>
+                                  <p:tgtEl>
+                                    <p:spTgt spid="6"/>
+                                  </p:tgtEl>
+                                  <p:attrNameLst>
+                                    <p:attrName>ppt_x</p:attrName>
+                                    <p:attrName>ppt_y</p:attrName>
+                                  </p:attrNameLst>
+                                </p:cBhvr>
+                              </p:animMotion>
                             </p:childTnLst>
                           </p:cTn>
                         </p:par>

</xml_diff>